<commit_message>
fix(layout): fix text overflow on 4 problem slides
修復 4 張最嚴重的字重疊投影片：

- 04-skills Slide 21 (控制誰能叫用 Skill)
  表格高度 3.5 → 2.8，兩欄高度 1.4 → 1.7

- 06-hooks Slide 30 (安全性)
  整體往上移 0.5"，兩欄高度 1.3 → 2.4

- 06-hooks Slide 31 (除錯技巧)
  標題往上移，bullet list 往上移 0.35"

- 06-hooks Slide 35 (編輯後跑測試)
  右側 async 註解整合進 code block
</commit_message>
<xml_diff>
--- a/04-skills.pptx
+++ b/04-skills.pptx
@@ -11743,7 +11743,7 @@
         </p:nvGraphicFramePr>
         <p:xfrm>
           <a:off x="457200" y="1554480"/>
-          <a:ext cx="11277295" cy="3200400"/>
+          <a:ext cx="11277295" cy="2560320"/>
         </p:xfrm>
         <a:graphic>
           <a:graphicData uri="http://schemas.openxmlformats.org/drawingml/2006/table">
@@ -11757,7 +11757,7 @@
                 <a:gridCol w="2819323"/>
                 <a:gridCol w="2819326"/>
               </a:tblGrid>
-              <a:tr h="800100">
+              <a:tr h="640080">
                 <a:tc>
                   <a:txBody>
                     <a:bodyPr lIns="45720" rIns="45720"/>
@@ -11851,7 +11851,7 @@
                   </a:tcPr>
                 </a:tc>
               </a:tr>
-              <a:tr h="800100">
+              <a:tr h="640080">
                 <a:tc>
                   <a:txBody>
                     <a:bodyPr lIns="45720" rIns="45720" tIns="36576" bIns="36576" wrap="square"/>
@@ -11945,7 +11945,7 @@
                   </a:tcPr>
                 </a:tc>
               </a:tr>
-              <a:tr h="800100">
+              <a:tr h="640080">
                 <a:tc>
                   <a:txBody>
                     <a:bodyPr lIns="45720" rIns="45720" tIns="36576" bIns="36576" wrap="square"/>
@@ -12039,7 +12039,7 @@
                   </a:tcPr>
                 </a:tc>
               </a:tr>
-              <a:tr h="800100">
+              <a:tr h="640080">
                 <a:tc>
                   <a:txBody>
                     <a:bodyPr lIns="45720" rIns="45720" tIns="36576" bIns="36576" wrap="square"/>
@@ -12145,7 +12145,7 @@
         </p:nvSpPr>
         <p:spPr>
           <a:xfrm>
-            <a:off x="457200" y="4937760"/>
+            <a:off x="457200" y="4297680"/>
             <a:ext cx="11277295" cy="365760"/>
           </a:xfrm>
           <a:prstGeom prst="rect">
@@ -12180,8 +12180,8 @@
         </p:nvSpPr>
         <p:spPr>
           <a:xfrm>
-            <a:off x="457200" y="5303520"/>
-            <a:ext cx="5577840" cy="1280160"/>
+            <a:off x="457200" y="4663440"/>
+            <a:ext cx="5577840" cy="1554480"/>
           </a:xfrm>
           <a:prstGeom prst="roundRect">
             <a:avLst/>
@@ -12225,7 +12225,7 @@
         </p:nvSpPr>
         <p:spPr>
           <a:xfrm>
-            <a:off x="457200" y="5303520"/>
+            <a:off x="457200" y="4663440"/>
             <a:ext cx="5577840" cy="457200"/>
           </a:xfrm>
           <a:prstGeom prst="rect">
@@ -12268,7 +12268,7 @@
         </p:nvSpPr>
         <p:spPr>
           <a:xfrm>
-            <a:off x="457200" y="5303520"/>
+            <a:off x="457200" y="4663440"/>
             <a:ext cx="5577840" cy="457200"/>
           </a:xfrm>
           <a:prstGeom prst="rect">
@@ -12303,8 +12303,8 @@
         </p:nvSpPr>
         <p:spPr>
           <a:xfrm>
-            <a:off x="640080" y="5943600"/>
-            <a:ext cx="5212080" cy="548640"/>
+            <a:off x="640080" y="5303520"/>
+            <a:ext cx="5212080" cy="822960"/>
           </a:xfrm>
           <a:prstGeom prst="rect">
             <a:avLst/>
@@ -12374,8 +12374,8 @@
         </p:nvSpPr>
         <p:spPr>
           <a:xfrm>
-            <a:off x="6156655" y="5303520"/>
-            <a:ext cx="5577840" cy="1280160"/>
+            <a:off x="6156655" y="4663440"/>
+            <a:ext cx="5577840" cy="1554480"/>
           </a:xfrm>
           <a:prstGeom prst="roundRect">
             <a:avLst/>
@@ -12419,7 +12419,7 @@
         </p:nvSpPr>
         <p:spPr>
           <a:xfrm>
-            <a:off x="6156655" y="5303520"/>
+            <a:off x="6156655" y="4663440"/>
             <a:ext cx="5577840" cy="457200"/>
           </a:xfrm>
           <a:prstGeom prst="rect">
@@ -12462,7 +12462,7 @@
         </p:nvSpPr>
         <p:spPr>
           <a:xfrm>
-            <a:off x="6156655" y="5303520"/>
+            <a:off x="6156655" y="4663440"/>
             <a:ext cx="5577840" cy="457200"/>
           </a:xfrm>
           <a:prstGeom prst="rect">
@@ -12497,8 +12497,8 @@
         </p:nvSpPr>
         <p:spPr>
           <a:xfrm>
-            <a:off x="6339535" y="5943600"/>
-            <a:ext cx="5212080" cy="548640"/>
+            <a:off x="6339535" y="5303520"/>
+            <a:ext cx="5212080" cy="822960"/>
           </a:xfrm>
           <a:prstGeom prst="rect">
             <a:avLst/>

</xml_diff>